<commit_message>
feat: SIH 2026 repositioning, backend/frontend updates and demo assets
Updates across the FastAPI backend (main, ml, simulator) and the frontend
(app, charts, simulator, styles), a revised pitch deck and one-pager, and the
SIH 2026 theme-decision note plus the subtitled demo video.
</commit_message>
<xml_diff>
--- a/docs/MachineSenseAI_Pitch_Deck.pptx
+++ b/docs/MachineSenseAI_Pitch_Deck.pptx
@@ -3309,7 +3309,7 @@
                 </a:solidFill>
                 <a:latin typeface="Century Schoolbook"/>
               </a:rPr>
-              <a:t>Explainable Industrial Intelligence for MSMEs</a:t>
+              <a:t>Explainable Industrial Intelligence for Indian Industry</a:t>
             </a:r>
           </a:p>
         </p:txBody>
@@ -3435,7 +3435,7 @@
                 </a:solidFill>
                 <a:latin typeface="Century Schoolbook"/>
               </a:rPr>
-              <a:t>₹19.8L</a:t>
+              <a:t>SIH 2026</a:t>
             </a:r>
           </a:p>
         </p:txBody>
@@ -3474,7 +3474,7 @@
                 </a:solidFill>
                 <a:latin typeface="Calibri"/>
               </a:rPr>
-              <a:t>PROJECT COST</a:t>
+              <a:t>SOFTWARE EDITION</a:t>
             </a:r>
           </a:p>
         </p:txBody>
@@ -3600,7 +3600,7 @@
                 </a:solidFill>
                 <a:latin typeface="Calibri"/>
               </a:rPr>
-              <a:t>TARGET MSMES</a:t>
+              <a:t>FACTORIES &amp; WORKSHOPS</a:t>
             </a:r>
           </a:p>
         </p:txBody>
@@ -3813,7 +3813,7 @@
                 </a:solidFill>
                 <a:latin typeface="Century Schoolbook"/>
               </a:rPr>
-              <a:t>SaaS + Kit</a:t>
+              <a:t>Working</a:t>
             </a:r>
           </a:p>
         </p:txBody>
@@ -3852,7 +3852,7 @@
                 </a:solidFill>
                 <a:latin typeface="Calibri"/>
               </a:rPr>
-              <a:t>BUSINESS MODEL</a:t>
+              <a:t>PROTOTYPE STATUS</a:t>
             </a:r>
           </a:p>
         </p:txBody>
@@ -3891,7 +3891,7 @@
                 </a:solidFill>
                 <a:latin typeface="Calibri"/>
               </a:rPr>
-              <a:t>MSME Idea Hackathon  ·  Industry 4.0 · AI · IoT · Digital Twin</a:t>
+              <a:t>Smart India Hackathon 2026  ·  Industry 4.0 · AI · IoT · Digital Twin</a:t>
             </a:r>
           </a:p>
         </p:txBody>
@@ -5539,7 +5539,7 @@
                 </a:solidFill>
                 <a:latin typeface="Calibri"/>
               </a:rPr>
-              <a:t>Field pilots with MSMEs, hardware kit, mobile app</a:t>
+              <a:t>Field pilots with industry partners, hardware kit, mobile app</a:t>
             </a:r>
           </a:p>
         </p:txBody>
@@ -6008,7 +6008,7 @@
                 </a:solidFill>
                 <a:latin typeface="Century Schoolbook"/>
               </a:rPr>
-              <a:t>for every MSME.</a:t>
+              <a:t>for every Indian factory.</a:t>
             </a:r>
           </a:p>
         </p:txBody>
@@ -6425,7 +6425,7 @@
                 </a:solidFill>
                 <a:latin typeface="Calibri"/>
               </a:rPr>
-              <a:t>Seeking partners &amp; MSMEs</a:t>
+              <a:t>Seeking industry partners</a:t>
             </a:r>
           </a:p>
         </p:txBody>
@@ -6464,7 +6464,7 @@
                 </a:solidFill>
                 <a:latin typeface="Calibri"/>
               </a:rPr>
-              <a:t>Thank you  ·  MachineSense AI  ·  MSME Idea Hackathon</a:t>
+              <a:t>Thank you  ·  MachineSense AI  ·  Smart India Hackathon 2026</a:t>
             </a:r>
           </a:p>
         </p:txBody>
@@ -6650,7 +6650,7 @@
                 </a:solidFill>
                 <a:latin typeface="Century Schoolbook"/>
               </a:rPr>
-              <a:t>MSMEs are flying blind on machine health</a:t>
+              <a:t>Indian factories are flying blind on machine health</a:t>
             </a:r>
           </a:p>
         </p:txBody>
@@ -7322,7 +7322,7 @@
                 </a:solidFill>
                 <a:latin typeface="Calibri"/>
               </a:rPr>
-              <a:t>Inefficient, ageing machines silently burn excess power — a cost few MSMEs even measure.</a:t>
+              <a:t>Inefficient, ageing machines silently burn excess power — a cost few factories even measure.</a:t>
             </a:r>
           </a:p>
         </p:txBody>
@@ -12701,7 +12701,7 @@
                 </a:solidFill>
                 <a:latin typeface="Calibri"/>
               </a:rPr>
-              <a:t>Affordable · MSME-first · Explainable · Twin-validated — an integrated platform, not a point tool.</a:t>
+              <a:t>Affordable · India-first · Explainable · Twin-validated — an integrated platform, not a point tool.</a:t>
             </a:r>
           </a:p>
         </p:txBody>
@@ -14762,7 +14762,7 @@
                 </a:solidFill>
                 <a:latin typeface="Calibri"/>
               </a:rPr>
-              <a:t>MSMEs in India seeking
+              <a:t>factories &amp; workshops seeking
 affordable digitisation</a:t>
             </a:r>
           </a:p>

</xml_diff>